<commit_message>
Add slide on instruction detail and efficiency
</commit_message>
<xml_diff>
--- a/presentation.pptx
+++ b/presentation.pptx
@@ -17,6 +17,7 @@
     <p:sldId id="265" r:id="rId11"/>
     <p:sldId id="266" r:id="rId12"/>
     <p:sldId id="267" r:id="rId13"/>
+    <p:sldId id="268" r:id="rId14"/>
   </p:sldIdLst>
   <p:sldSz cx="15240000" cy="8572500" type="screen16x9"/>
   <p:notesSz cx="6858000" cy="9144000"/>
@@ -246,6 +247,55 @@
       <p:pic>
         <p:nvPicPr>
           <p:cNvPr id="2" name="Slide 12" descr="HTML slide 12 rendered at 3200 by 1800"/>
+          <p:cNvPicPr>
+            <a:picLocks noChangeAspect="1"/>
+          </p:cNvPicPr>
+          <p:nvPr/>
+        </p:nvPicPr>
+        <p:blipFill>
+          <a:blip r:embed="rId2"/>
+          <a:stretch>
+            <a:fillRect/>
+          </a:stretch>
+        </p:blipFill>
+        <p:spPr>
+          <a:xfrm>
+            <a:off x="0" y="0"/>
+            <a:ext cx="15240000" cy="8572500"/>
+          </a:xfrm>
+          <a:prstGeom prst="rect">
+            <a:avLst/>
+          </a:prstGeom>
+        </p:spPr>
+      </p:pic>
+    </p:spTree>
+  </p:cSld>
+  <p:clrMapOvr>
+    <a:masterClrMapping/>
+  </p:clrMapOvr>
+</p:sld>
+</file>
+
+<file path=ppt/slides/slide13.xml><?xml version="1.0" encoding="utf-8"?>
+<p:sld xmlns:p="http://schemas.openxmlformats.org/presentationml/2006/main" xmlns:a="http://schemas.openxmlformats.org/drawingml/2006/main" xmlns:r="http://schemas.openxmlformats.org/officeDocument/2006/relationships">
+  <p:cSld name="Slide 13">
+    <p:spTree>
+      <p:nvGrpSpPr>
+        <p:cNvPr id="1" name=""/>
+        <p:cNvGrpSpPr/>
+        <p:nvPr/>
+      </p:nvGrpSpPr>
+      <p:grpSpPr>
+        <a:xfrm>
+          <a:off x="0" y="0"/>
+          <a:ext cx="0" cy="0"/>
+          <a:chOff x="0" y="0"/>
+          <a:chExt cx="0" cy="0"/>
+        </a:xfrm>
+      </p:grpSpPr>
+      <p:pic>
+        <p:nvPicPr>
+          <p:cNvPr id="2" name="Slide 13" descr="HTML slide 13 rendered at 3200 by 1800"/>
           <p:cNvPicPr>
             <a:picLocks noChangeAspect="1"/>
           </p:cNvPicPr>

</xml_diff>

<commit_message>
Add AI purpose slide and reorder presentation
</commit_message>
<xml_diff>
--- a/presentation.pptx
+++ b/presentation.pptx
@@ -18,6 +18,7 @@
     <p:sldId id="266" r:id="rId12"/>
     <p:sldId id="267" r:id="rId13"/>
     <p:sldId id="268" r:id="rId14"/>
+    <p:sldId id="269" r:id="rId15"/>
   </p:sldIdLst>
   <p:sldSz cx="15240000" cy="8572500" type="screen16x9"/>
   <p:notesSz cx="6858000" cy="9144000"/>
@@ -296,6 +297,55 @@
       <p:pic>
         <p:nvPicPr>
           <p:cNvPr id="2" name="Slide 13" descr="HTML slide 13 rendered at 3200 by 1800"/>
+          <p:cNvPicPr>
+            <a:picLocks noChangeAspect="1"/>
+          </p:cNvPicPr>
+          <p:nvPr/>
+        </p:nvPicPr>
+        <p:blipFill>
+          <a:blip r:embed="rId2"/>
+          <a:stretch>
+            <a:fillRect/>
+          </a:stretch>
+        </p:blipFill>
+        <p:spPr>
+          <a:xfrm>
+            <a:off x="0" y="0"/>
+            <a:ext cx="15240000" cy="8572500"/>
+          </a:xfrm>
+          <a:prstGeom prst="rect">
+            <a:avLst/>
+          </a:prstGeom>
+        </p:spPr>
+      </p:pic>
+    </p:spTree>
+  </p:cSld>
+  <p:clrMapOvr>
+    <a:masterClrMapping/>
+  </p:clrMapOvr>
+</p:sld>
+</file>
+
+<file path=ppt/slides/slide14.xml><?xml version="1.0" encoding="utf-8"?>
+<p:sld xmlns:p="http://schemas.openxmlformats.org/presentationml/2006/main" xmlns:a="http://schemas.openxmlformats.org/drawingml/2006/main" xmlns:r="http://schemas.openxmlformats.org/officeDocument/2006/relationships">
+  <p:cSld name="Slide 14">
+    <p:spTree>
+      <p:nvGrpSpPr>
+        <p:cNvPr id="1" name=""/>
+        <p:cNvGrpSpPr/>
+        <p:nvPr/>
+      </p:nvGrpSpPr>
+      <p:grpSpPr>
+        <a:xfrm>
+          <a:off x="0" y="0"/>
+          <a:ext cx="0" cy="0"/>
+          <a:chOff x="0" y="0"/>
+          <a:chExt cx="0" cy="0"/>
+        </a:xfrm>
+      </p:grpSpPr>
+      <p:pic>
+        <p:nvPicPr>
+          <p:cNvPr id="2" name="Slide 14" descr="HTML slide 14 rendered at 3200 by 1800"/>
           <p:cNvPicPr>
             <a:picLocks noChangeAspect="1"/>
           </p:cNvPicPr>

</xml_diff>

<commit_message>
Update presentation to revised 16-slide version
</commit_message>
<xml_diff>
--- a/presentation.pptx
+++ b/presentation.pptx
@@ -19,6 +19,8 @@
     <p:sldId id="267" r:id="rId13"/>
     <p:sldId id="268" r:id="rId14"/>
     <p:sldId id="269" r:id="rId15"/>
+    <p:sldId id="270" r:id="rId16"/>
+    <p:sldId id="271" r:id="rId17"/>
   </p:sldIdLst>
   <p:sldSz cx="15240000" cy="8572500" type="screen16x9"/>
   <p:notesSz cx="6858000" cy="9144000"/>
@@ -346,6 +348,104 @@
       <p:pic>
         <p:nvPicPr>
           <p:cNvPr id="2" name="Slide 14" descr="HTML slide 14 rendered at 3200 by 1800"/>
+          <p:cNvPicPr>
+            <a:picLocks noChangeAspect="1"/>
+          </p:cNvPicPr>
+          <p:nvPr/>
+        </p:nvPicPr>
+        <p:blipFill>
+          <a:blip r:embed="rId2"/>
+          <a:stretch>
+            <a:fillRect/>
+          </a:stretch>
+        </p:blipFill>
+        <p:spPr>
+          <a:xfrm>
+            <a:off x="0" y="0"/>
+            <a:ext cx="15240000" cy="8572500"/>
+          </a:xfrm>
+          <a:prstGeom prst="rect">
+            <a:avLst/>
+          </a:prstGeom>
+        </p:spPr>
+      </p:pic>
+    </p:spTree>
+  </p:cSld>
+  <p:clrMapOvr>
+    <a:masterClrMapping/>
+  </p:clrMapOvr>
+</p:sld>
+</file>
+
+<file path=ppt/slides/slide15.xml><?xml version="1.0" encoding="utf-8"?>
+<p:sld xmlns:p="http://schemas.openxmlformats.org/presentationml/2006/main" xmlns:a="http://schemas.openxmlformats.org/drawingml/2006/main" xmlns:r="http://schemas.openxmlformats.org/officeDocument/2006/relationships">
+  <p:cSld name="Slide 15">
+    <p:spTree>
+      <p:nvGrpSpPr>
+        <p:cNvPr id="1" name=""/>
+        <p:cNvGrpSpPr/>
+        <p:nvPr/>
+      </p:nvGrpSpPr>
+      <p:grpSpPr>
+        <a:xfrm>
+          <a:off x="0" y="0"/>
+          <a:ext cx="0" cy="0"/>
+          <a:chOff x="0" y="0"/>
+          <a:chExt cx="0" cy="0"/>
+        </a:xfrm>
+      </p:grpSpPr>
+      <p:pic>
+        <p:nvPicPr>
+          <p:cNvPr id="2" name="Slide 15" descr="HTML slide 15 rendered at 3200 by 1800"/>
+          <p:cNvPicPr>
+            <a:picLocks noChangeAspect="1"/>
+          </p:cNvPicPr>
+          <p:nvPr/>
+        </p:nvPicPr>
+        <p:blipFill>
+          <a:blip r:embed="rId2"/>
+          <a:stretch>
+            <a:fillRect/>
+          </a:stretch>
+        </p:blipFill>
+        <p:spPr>
+          <a:xfrm>
+            <a:off x="0" y="0"/>
+            <a:ext cx="15240000" cy="8572500"/>
+          </a:xfrm>
+          <a:prstGeom prst="rect">
+            <a:avLst/>
+          </a:prstGeom>
+        </p:spPr>
+      </p:pic>
+    </p:spTree>
+  </p:cSld>
+  <p:clrMapOvr>
+    <a:masterClrMapping/>
+  </p:clrMapOvr>
+</p:sld>
+</file>
+
+<file path=ppt/slides/slide16.xml><?xml version="1.0" encoding="utf-8"?>
+<p:sld xmlns:p="http://schemas.openxmlformats.org/presentationml/2006/main" xmlns:a="http://schemas.openxmlformats.org/drawingml/2006/main" xmlns:r="http://schemas.openxmlformats.org/officeDocument/2006/relationships">
+  <p:cSld name="Slide 16">
+    <p:spTree>
+      <p:nvGrpSpPr>
+        <p:cNvPr id="1" name=""/>
+        <p:cNvGrpSpPr/>
+        <p:nvPr/>
+      </p:nvGrpSpPr>
+      <p:grpSpPr>
+        <a:xfrm>
+          <a:off x="0" y="0"/>
+          <a:ext cx="0" cy="0"/>
+          <a:chOff x="0" y="0"/>
+          <a:chExt cx="0" cy="0"/>
+        </a:xfrm>
+      </p:grpSpPr>
+      <p:pic>
+        <p:nvPicPr>
+          <p:cNvPr id="2" name="Slide 16" descr="HTML slide 16 rendered at 3200 by 1800"/>
           <p:cNvPicPr>
             <a:picLocks noChangeAspect="1"/>
           </p:cNvPicPr>

</xml_diff>

<commit_message>
Add design decisions and frame delegation from manager perspective
</commit_message>
<xml_diff>
--- a/presentation.pptx
+++ b/presentation.pptx
@@ -21,6 +21,7 @@
     <p:sldId id="269" r:id="rId15"/>
     <p:sldId id="270" r:id="rId16"/>
     <p:sldId id="271" r:id="rId17"/>
+    <p:sldId id="272" r:id="rId18"/>
   </p:sldIdLst>
   <p:sldSz cx="15240000" cy="8572500" type="screen16x9"/>
   <p:notesSz cx="6858000" cy="9144000"/>
@@ -446,6 +447,55 @@
       <p:pic>
         <p:nvPicPr>
           <p:cNvPr id="2" name="Slide 16" descr="HTML slide 16 rendered at 3200 by 1800"/>
+          <p:cNvPicPr>
+            <a:picLocks noChangeAspect="1"/>
+          </p:cNvPicPr>
+          <p:nvPr/>
+        </p:nvPicPr>
+        <p:blipFill>
+          <a:blip r:embed="rId2"/>
+          <a:stretch>
+            <a:fillRect/>
+          </a:stretch>
+        </p:blipFill>
+        <p:spPr>
+          <a:xfrm>
+            <a:off x="0" y="0"/>
+            <a:ext cx="15240000" cy="8572500"/>
+          </a:xfrm>
+          <a:prstGeom prst="rect">
+            <a:avLst/>
+          </a:prstGeom>
+        </p:spPr>
+      </p:pic>
+    </p:spTree>
+  </p:cSld>
+  <p:clrMapOvr>
+    <a:masterClrMapping/>
+  </p:clrMapOvr>
+</p:sld>
+</file>
+
+<file path=ppt/slides/slide17.xml><?xml version="1.0" encoding="utf-8"?>
+<p:sld xmlns:p="http://schemas.openxmlformats.org/presentationml/2006/main" xmlns:a="http://schemas.openxmlformats.org/drawingml/2006/main" xmlns:r="http://schemas.openxmlformats.org/officeDocument/2006/relationships">
+  <p:cSld name="Slide 17">
+    <p:spTree>
+      <p:nvGrpSpPr>
+        <p:cNvPr id="1" name=""/>
+        <p:cNvGrpSpPr/>
+        <p:nvPr/>
+      </p:nvGrpSpPr>
+      <p:grpSpPr>
+        <a:xfrm>
+          <a:off x="0" y="0"/>
+          <a:ext cx="0" cy="0"/>
+          <a:chOff x="0" y="0"/>
+          <a:chExt cx="0" cy="0"/>
+        </a:xfrm>
+      </p:grpSpPr>
+      <p:pic>
+        <p:nvPicPr>
+          <p:cNvPr id="2" name="Slide 17" descr="HTML slide 17 rendered at 3200 by 1800"/>
           <p:cNvPicPr>
             <a:picLocks noChangeAspect="1"/>
           </p:cNvPicPr>

</xml_diff>

<commit_message>
Consolidate closing slides into learning and future plans
</commit_message>
<xml_diff>
--- a/presentation.pptx
+++ b/presentation.pptx
@@ -19,9 +19,6 @@
     <p:sldId id="267" r:id="rId13"/>
     <p:sldId id="268" r:id="rId14"/>
     <p:sldId id="269" r:id="rId15"/>
-    <p:sldId id="270" r:id="rId16"/>
-    <p:sldId id="271" r:id="rId17"/>
-    <p:sldId id="272" r:id="rId18"/>
   </p:sldIdLst>
   <p:sldSz cx="15240000" cy="8572500" type="screen16x9"/>
   <p:notesSz cx="6858000" cy="9144000"/>
@@ -349,153 +346,6 @@
       <p:pic>
         <p:nvPicPr>
           <p:cNvPr id="2" name="Slide 14" descr="HTML slide 14 rendered at 3200 by 1800"/>
-          <p:cNvPicPr>
-            <a:picLocks noChangeAspect="1"/>
-          </p:cNvPicPr>
-          <p:nvPr/>
-        </p:nvPicPr>
-        <p:blipFill>
-          <a:blip r:embed="rId2"/>
-          <a:stretch>
-            <a:fillRect/>
-          </a:stretch>
-        </p:blipFill>
-        <p:spPr>
-          <a:xfrm>
-            <a:off x="0" y="0"/>
-            <a:ext cx="15240000" cy="8572500"/>
-          </a:xfrm>
-          <a:prstGeom prst="rect">
-            <a:avLst/>
-          </a:prstGeom>
-        </p:spPr>
-      </p:pic>
-    </p:spTree>
-  </p:cSld>
-  <p:clrMapOvr>
-    <a:masterClrMapping/>
-  </p:clrMapOvr>
-</p:sld>
-</file>
-
-<file path=ppt/slides/slide15.xml><?xml version="1.0" encoding="utf-8"?>
-<p:sld xmlns:p="http://schemas.openxmlformats.org/presentationml/2006/main" xmlns:a="http://schemas.openxmlformats.org/drawingml/2006/main" xmlns:r="http://schemas.openxmlformats.org/officeDocument/2006/relationships">
-  <p:cSld name="Slide 15">
-    <p:spTree>
-      <p:nvGrpSpPr>
-        <p:cNvPr id="1" name=""/>
-        <p:cNvGrpSpPr/>
-        <p:nvPr/>
-      </p:nvGrpSpPr>
-      <p:grpSpPr>
-        <a:xfrm>
-          <a:off x="0" y="0"/>
-          <a:ext cx="0" cy="0"/>
-          <a:chOff x="0" y="0"/>
-          <a:chExt cx="0" cy="0"/>
-        </a:xfrm>
-      </p:grpSpPr>
-      <p:pic>
-        <p:nvPicPr>
-          <p:cNvPr id="2" name="Slide 15" descr="HTML slide 15 rendered at 3200 by 1800"/>
-          <p:cNvPicPr>
-            <a:picLocks noChangeAspect="1"/>
-          </p:cNvPicPr>
-          <p:nvPr/>
-        </p:nvPicPr>
-        <p:blipFill>
-          <a:blip r:embed="rId2"/>
-          <a:stretch>
-            <a:fillRect/>
-          </a:stretch>
-        </p:blipFill>
-        <p:spPr>
-          <a:xfrm>
-            <a:off x="0" y="0"/>
-            <a:ext cx="15240000" cy="8572500"/>
-          </a:xfrm>
-          <a:prstGeom prst="rect">
-            <a:avLst/>
-          </a:prstGeom>
-        </p:spPr>
-      </p:pic>
-    </p:spTree>
-  </p:cSld>
-  <p:clrMapOvr>
-    <a:masterClrMapping/>
-  </p:clrMapOvr>
-</p:sld>
-</file>
-
-<file path=ppt/slides/slide16.xml><?xml version="1.0" encoding="utf-8"?>
-<p:sld xmlns:p="http://schemas.openxmlformats.org/presentationml/2006/main" xmlns:a="http://schemas.openxmlformats.org/drawingml/2006/main" xmlns:r="http://schemas.openxmlformats.org/officeDocument/2006/relationships">
-  <p:cSld name="Slide 16">
-    <p:spTree>
-      <p:nvGrpSpPr>
-        <p:cNvPr id="1" name=""/>
-        <p:cNvGrpSpPr/>
-        <p:nvPr/>
-      </p:nvGrpSpPr>
-      <p:grpSpPr>
-        <a:xfrm>
-          <a:off x="0" y="0"/>
-          <a:ext cx="0" cy="0"/>
-          <a:chOff x="0" y="0"/>
-          <a:chExt cx="0" cy="0"/>
-        </a:xfrm>
-      </p:grpSpPr>
-      <p:pic>
-        <p:nvPicPr>
-          <p:cNvPr id="2" name="Slide 16" descr="HTML slide 16 rendered at 3200 by 1800"/>
-          <p:cNvPicPr>
-            <a:picLocks noChangeAspect="1"/>
-          </p:cNvPicPr>
-          <p:nvPr/>
-        </p:nvPicPr>
-        <p:blipFill>
-          <a:blip r:embed="rId2"/>
-          <a:stretch>
-            <a:fillRect/>
-          </a:stretch>
-        </p:blipFill>
-        <p:spPr>
-          <a:xfrm>
-            <a:off x="0" y="0"/>
-            <a:ext cx="15240000" cy="8572500"/>
-          </a:xfrm>
-          <a:prstGeom prst="rect">
-            <a:avLst/>
-          </a:prstGeom>
-        </p:spPr>
-      </p:pic>
-    </p:spTree>
-  </p:cSld>
-  <p:clrMapOvr>
-    <a:masterClrMapping/>
-  </p:clrMapOvr>
-</p:sld>
-</file>
-
-<file path=ppt/slides/slide17.xml><?xml version="1.0" encoding="utf-8"?>
-<p:sld xmlns:p="http://schemas.openxmlformats.org/presentationml/2006/main" xmlns:a="http://schemas.openxmlformats.org/drawingml/2006/main" xmlns:r="http://schemas.openxmlformats.org/officeDocument/2006/relationships">
-  <p:cSld name="Slide 17">
-    <p:spTree>
-      <p:nvGrpSpPr>
-        <p:cNvPr id="1" name=""/>
-        <p:cNvGrpSpPr/>
-        <p:nvPr/>
-      </p:nvGrpSpPr>
-      <p:grpSpPr>
-        <a:xfrm>
-          <a:off x="0" y="0"/>
-          <a:ext cx="0" cy="0"/>
-          <a:chOff x="0" y="0"/>
-          <a:chExt cx="0" cy="0"/>
-        </a:xfrm>
-      </p:grpSpPr>
-      <p:pic>
-        <p:nvPicPr>
-          <p:cNvPr id="2" name="Slide 17" descr="HTML slide 17 rendered at 3200 by 1800"/>
           <p:cNvPicPr>
             <a:picLocks noChangeAspect="1"/>
           </p:cNvPicPr>

</xml_diff>

<commit_message>
Add embedded app demo video as fourth slide
</commit_message>
<xml_diff>
--- a/presentation.pptx
+++ b/presentation.pptx
@@ -19,6 +19,7 @@
     <p:sldId id="267" r:id="rId13"/>
     <p:sldId id="268" r:id="rId14"/>
     <p:sldId id="269" r:id="rId15"/>
+    <p:sldId id="270" r:id="rId16"/>
   </p:sldIdLst>
   <p:sldSz cx="15240000" cy="8572500" type="screen16x9"/>
   <p:notesSz cx="6858000" cy="9144000"/>
@@ -346,6 +347,55 @@
       <p:pic>
         <p:nvPicPr>
           <p:cNvPr id="2" name="Slide 14" descr="HTML slide 14 rendered at 3200 by 1800"/>
+          <p:cNvPicPr>
+            <a:picLocks noChangeAspect="1"/>
+          </p:cNvPicPr>
+          <p:nvPr/>
+        </p:nvPicPr>
+        <p:blipFill>
+          <a:blip r:embed="rId2"/>
+          <a:stretch>
+            <a:fillRect/>
+          </a:stretch>
+        </p:blipFill>
+        <p:spPr>
+          <a:xfrm>
+            <a:off x="0" y="0"/>
+            <a:ext cx="15240000" cy="8572500"/>
+          </a:xfrm>
+          <a:prstGeom prst="rect">
+            <a:avLst/>
+          </a:prstGeom>
+        </p:spPr>
+      </p:pic>
+    </p:spTree>
+  </p:cSld>
+  <p:clrMapOvr>
+    <a:masterClrMapping/>
+  </p:clrMapOvr>
+</p:sld>
+</file>
+
+<file path=ppt/slides/slide15.xml><?xml version="1.0" encoding="utf-8"?>
+<p:sld xmlns:p="http://schemas.openxmlformats.org/presentationml/2006/main" xmlns:a="http://schemas.openxmlformats.org/drawingml/2006/main" xmlns:r="http://schemas.openxmlformats.org/officeDocument/2006/relationships">
+  <p:cSld name="Slide 15">
+    <p:spTree>
+      <p:nvGrpSpPr>
+        <p:cNvPr id="1" name=""/>
+        <p:cNvGrpSpPr/>
+        <p:nvPr/>
+      </p:nvGrpSpPr>
+      <p:grpSpPr>
+        <a:xfrm>
+          <a:off x="0" y="0"/>
+          <a:ext cx="0" cy="0"/>
+          <a:chOff x="0" y="0"/>
+          <a:chExt cx="0" cy="0"/>
+        </a:xfrm>
+      </p:grpSpPr>
+      <p:pic>
+        <p:nvPicPr>
+          <p:cNvPr id="2" name="Slide 15" descr="HTML slide 15 rendered at 3200 by 1800"/>
           <p:cNvPicPr>
             <a:picLocks noChangeAspect="1"/>
           </p:cNvPicPr>

</xml_diff>